<commit_message>
Equatorial Telecom: ajusta menções ao Facebook (agência sem acesso à página)
Co-Authored-By: Claude Opus 5.5 <noreply@anthropic.com>
Claude-Session: https://claude.ai/code/session_018aor3gsZX6WscNn4yXKg1c
</commit_message>
<xml_diff>
--- a/relatorios/maximize/pptx/eqtl-telecom-setembro-2026.pptx
+++ b/relatorios/maximize/pptx/eqtl-telecom-setembro-2026.pptx
@@ -5760,7 +5760,7 @@
         <p:spPr>
           <a:xfrm>
             <a:off x="942975" y="2276475"/>
-            <a:ext cx="5174605" cy="152400"/>
+            <a:ext cx="7775674" cy="152400"/>
           </a:xfrm>
           <a:prstGeom prst="rect">
             <a:avLst/>
@@ -5799,7 +5799,7 @@
                 </a:solidFill>
                 <a:latin typeface="Montserrat"/>
               </a:rPr>
-              <a:t> página sem publicações em setembro, com 24 visualizações e 23 visitas.</a:t>
+              <a:t> sem publicações, já que a agência não tem acesso à página; ainda assim, ela registrou 24 visualizações e 23 visitas.</a:t>
             </a:r>
           </a:p>
         </p:txBody>
@@ -6140,7 +6140,7 @@
         <p:spPr>
           <a:xfrm>
             <a:off x="942975" y="5376862"/>
-            <a:ext cx="6018461" cy="152400"/>
+            <a:ext cx="6316563" cy="152400"/>
           </a:xfrm>
           <a:prstGeom prst="rect">
             <a:avLst/>
@@ -6170,7 +6170,7 @@
                 </a:solidFill>
                 <a:latin typeface="Montserrat"/>
               </a:rPr>
-              <a:t>Retomar </a:t>
+              <a:t>Retomar os </a:t>
             </a:r>
             <a:r>
               <a:rPr sz="1000" b="1" i="0">
@@ -6188,7 +6188,7 @@
                 </a:solidFill>
                 <a:latin typeface="Montserrat"/>
               </a:rPr>
-              <a:t> (nenhum publicado em setembro) e avaliar a replicação dos posts no Facebook.</a:t>
+              <a:t> (nenhum publicado em setembro) com bastidores e enquetes do Dicionário Tech.</a:t>
             </a:r>
           </a:p>
         </p:txBody>
@@ -6843,7 +6843,7 @@
                 </a:solidFill>
                 <a:latin typeface="Montserrat"/>
               </a:rPr>
-              <a:t>Stories e Facebook parados:</a:t>
+              <a:t>Stories parados:</a:t>
             </a:r>
             <a:r>
               <a:rPr sz="1000" b="0" i="0">
@@ -6852,7 +6852,7 @@
                 </a:solidFill>
                 <a:latin typeface="Montserrat"/>
               </a:rPr>
-              <a:t> nenhum story e nenhuma publicação na página em setembro.</a:t>
+              <a:t> nenhum story publicado em setembro.</a:t>
             </a:r>
           </a:p>
         </p:txBody>
@@ -9578,7 +9578,7 @@
                 </a:solidFill>
                 <a:latin typeface="Montserrat"/>
               </a:rPr>
-              <a:t>sem publicações</a:t>
+              <a:t>sem publicações: a agência</a:t>
             </a:r>
           </a:p>
           <a:p>
@@ -9594,7 +9594,7 @@
                 </a:solidFill>
                 <a:latin typeface="Montserrat"/>
               </a:rPr>
-              <a:t>na página no mês</a:t>
+              <a:t>não tem acesso à página</a:t>
             </a:r>
           </a:p>
         </p:txBody>
@@ -9838,7 +9838,7 @@
                 </a:solidFill>
                 <a:latin typeface="Montserrat"/>
               </a:rPr>
-              <a:t>. Taxa de engajamento calculada como interações ÷ alcance (glossário); o valor publicado em agosto (1%) seguiu outra base, por isso não há comparação direta. Facebook: variações calculadas pelo próprio Meta.</a:t>
+              <a:t>. Taxa de engajamento calculada como interações ÷ alcance (glossário); o valor publicado em agosto (1%) seguiu outra base, por isso não há comparação direta. Facebook: variações calculadas pelo próprio Meta; a agência não tem acesso de publicação à página, por isso os conteúdos não são replicados nela.</a:t>
             </a:r>
           </a:p>
         </p:txBody>

</xml_diff>